<commit_message>
Made 2d intersection builder slide
</commit_message>
<xml_diff>
--- a/Traffic-Simulator.pptx
+++ b/Traffic-Simulator.pptx
@@ -6,7 +6,8 @@
   </p:sldMasterIdLst>
   <p:sldIdLst>
     <p:sldId id="256" r:id="rId2"/>
-    <p:sldId id="257" r:id="rId3"/>
+    <p:sldId id="258" r:id="rId3"/>
+    <p:sldId id="257" r:id="rId4"/>
   </p:sldIdLst>
   <p:sldSz cx="12192000" cy="6858000"/>
   <p:notesSz cx="6858000" cy="9144000"/>
@@ -105,6 +106,11 @@
       </a:defRPr>
     </a:lvl9pPr>
   </p:defaultTextStyle>
+  <p:extLst>
+    <p:ext uri="{EFAFB233-063F-42B5-8137-9DF3F51BA10A}">
+      <p15:sldGuideLst xmlns:p15="http://schemas.microsoft.com/office/powerpoint/2012/main"/>
+    </p:ext>
+  </p:extLst>
 </p:presentation>
 </file>
 
@@ -527,7 +533,7 @@
           <a:p>
             <a:fld id="{D4F53BF9-51A7-479A-9F82-F12307D0B401}" type="datetimeFigureOut">
               <a:rPr lang="en-US" smtClean="0"/>
-              <a:t>10/27/2026</a:t>
+              <a:t>10/29/2026</a:t>
             </a:fld>
             <a:endParaRPr lang="en-US"/>
           </a:p>
@@ -852,7 +858,7 @@
           <a:p>
             <a:fld id="{D4F53BF9-51A7-479A-9F82-F12307D0B401}" type="datetimeFigureOut">
               <a:rPr lang="en-US" smtClean="0"/>
-              <a:t>10/27/2026</a:t>
+              <a:t>10/29/2026</a:t>
             </a:fld>
             <a:endParaRPr lang="en-US"/>
           </a:p>
@@ -1111,7 +1117,7 @@
           <a:p>
             <a:fld id="{D4F53BF9-51A7-479A-9F82-F12307D0B401}" type="datetimeFigureOut">
               <a:rPr lang="en-US" smtClean="0"/>
-              <a:t>10/27/2026</a:t>
+              <a:t>10/29/2026</a:t>
             </a:fld>
             <a:endParaRPr lang="en-US"/>
           </a:p>
@@ -1376,7 +1382,7 @@
           <a:p>
             <a:fld id="{D4F53BF9-51A7-479A-9F82-F12307D0B401}" type="datetimeFigureOut">
               <a:rPr lang="en-US" smtClean="0"/>
-              <a:t>10/27/2026</a:t>
+              <a:t>10/29/2026</a:t>
             </a:fld>
             <a:endParaRPr lang="en-US"/>
           </a:p>
@@ -1646,7 +1652,7 @@
           <a:p>
             <a:fld id="{D4F53BF9-51A7-479A-9F82-F12307D0B401}" type="datetimeFigureOut">
               <a:rPr lang="en-US" smtClean="0"/>
-              <a:t>10/27/2026</a:t>
+              <a:t>10/29/2026</a:t>
             </a:fld>
             <a:endParaRPr lang="en-US"/>
           </a:p>
@@ -1923,7 +1929,7 @@
           <a:p>
             <a:fld id="{D4F53BF9-51A7-479A-9F82-F12307D0B401}" type="datetimeFigureOut">
               <a:rPr lang="en-US" smtClean="0"/>
-              <a:t>10/27/2026</a:t>
+              <a:t>10/29/2026</a:t>
             </a:fld>
             <a:endParaRPr lang="en-US"/>
           </a:p>
@@ -2287,7 +2293,7 @@
           <a:p>
             <a:fld id="{D4F53BF9-51A7-479A-9F82-F12307D0B401}" type="datetimeFigureOut">
               <a:rPr lang="en-US" smtClean="0"/>
-              <a:t>10/27/2026</a:t>
+              <a:t>10/29/2026</a:t>
             </a:fld>
             <a:endParaRPr lang="en-US"/>
           </a:p>
@@ -2582,7 +2588,7 @@
           <a:p>
             <a:fld id="{D4F53BF9-51A7-479A-9F82-F12307D0B401}" type="datetimeFigureOut">
               <a:rPr lang="en-US" smtClean="0"/>
-              <a:t>10/27/2026</a:t>
+              <a:t>10/29/2026</a:t>
             </a:fld>
             <a:endParaRPr lang="en-US"/>
           </a:p>
@@ -2857,7 +2863,7 @@
           <a:p>
             <a:fld id="{D4F53BF9-51A7-479A-9F82-F12307D0B401}" type="datetimeFigureOut">
               <a:rPr lang="en-US" smtClean="0"/>
-              <a:t>10/27/2026</a:t>
+              <a:t>10/29/2026</a:t>
             </a:fld>
             <a:endParaRPr lang="en-US"/>
           </a:p>
@@ -3184,7 +3190,7 @@
           <a:p>
             <a:fld id="{D4F53BF9-51A7-479A-9F82-F12307D0B401}" type="datetimeFigureOut">
               <a:rPr lang="en-US" smtClean="0"/>
-              <a:t>10/27/2026</a:t>
+              <a:t>10/29/2026</a:t>
             </a:fld>
             <a:endParaRPr lang="en-US"/>
           </a:p>
@@ -3486,7 +3492,7 @@
           <a:p>
             <a:fld id="{D4F53BF9-51A7-479A-9F82-F12307D0B401}" type="datetimeFigureOut">
               <a:rPr lang="en-US" smtClean="0"/>
-              <a:t>10/27/2026</a:t>
+              <a:t>10/29/2026</a:t>
             </a:fld>
             <a:endParaRPr lang="en-US"/>
           </a:p>
@@ -3758,7 +3764,7 @@
           <a:p>
             <a:fld id="{D4F53BF9-51A7-479A-9F82-F12307D0B401}" type="datetimeFigureOut">
               <a:rPr lang="en-US" smtClean="0"/>
-              <a:t>10/27/2026</a:t>
+              <a:t>10/29/2026</a:t>
             </a:fld>
             <a:endParaRPr lang="en-US"/>
           </a:p>
@@ -4157,7 +4163,7 @@
           <a:p>
             <a:fld id="{D4F53BF9-51A7-479A-9F82-F12307D0B401}" type="datetimeFigureOut">
               <a:rPr lang="en-US" smtClean="0"/>
-              <a:t>10/27/2026</a:t>
+              <a:t>10/29/2026</a:t>
             </a:fld>
             <a:endParaRPr lang="en-US"/>
           </a:p>
@@ -4599,7 +4605,7 @@
           <a:p>
             <a:fld id="{D4F53BF9-51A7-479A-9F82-F12307D0B401}" type="datetimeFigureOut">
               <a:rPr lang="en-US" smtClean="0"/>
-              <a:t>10/27/2026</a:t>
+              <a:t>10/29/2026</a:t>
             </a:fld>
             <a:endParaRPr lang="en-US"/>
           </a:p>
@@ -4889,7 +4895,7 @@
           <a:p>
             <a:fld id="{D4F53BF9-51A7-479A-9F82-F12307D0B401}" type="datetimeFigureOut">
               <a:rPr lang="en-US" smtClean="0"/>
-              <a:t>10/27/2026</a:t>
+              <a:t>10/29/2026</a:t>
             </a:fld>
             <a:endParaRPr lang="en-US"/>
           </a:p>
@@ -5309,7 +5315,7 @@
           <a:p>
             <a:fld id="{D4F53BF9-51A7-479A-9F82-F12307D0B401}" type="datetimeFigureOut">
               <a:rPr lang="en-US" smtClean="0"/>
-              <a:t>10/27/2026</a:t>
+              <a:t>10/29/2026</a:t>
             </a:fld>
             <a:endParaRPr lang="en-US"/>
           </a:p>
@@ -5457,7 +5463,7 @@
           <a:p>
             <a:fld id="{D4F53BF9-51A7-479A-9F82-F12307D0B401}" type="datetimeFigureOut">
               <a:rPr lang="en-US" smtClean="0"/>
-              <a:t>10/27/2026</a:t>
+              <a:t>10/29/2026</a:t>
             </a:fld>
             <a:endParaRPr lang="en-US"/>
           </a:p>
@@ -5570,7 +5576,7 @@
           <a:p>
             <a:fld id="{D4F53BF9-51A7-479A-9F82-F12307D0B401}" type="datetimeFigureOut">
               <a:rPr lang="en-US" smtClean="0"/>
-              <a:t>10/27/2026</a:t>
+              <a:t>10/29/2026</a:t>
             </a:fld>
             <a:endParaRPr lang="en-US"/>
           </a:p>
@@ -5978,7 +5984,7 @@
           <a:p>
             <a:fld id="{D4F53BF9-51A7-479A-9F82-F12307D0B401}" type="datetimeFigureOut">
               <a:rPr lang="en-US" smtClean="0"/>
-              <a:t>10/27/2026</a:t>
+              <a:t>10/29/2026</a:t>
             </a:fld>
             <a:endParaRPr lang="en-US"/>
           </a:p>
@@ -6427,7 +6433,7 @@
           <a:p>
             <a:fld id="{D4F53BF9-51A7-479A-9F82-F12307D0B401}" type="datetimeFigureOut">
               <a:rPr lang="en-US" smtClean="0"/>
-              <a:t>10/27/2026</a:t>
+              <a:t>10/29/2026</a:t>
             </a:fld>
             <a:endParaRPr lang="en-US"/>
           </a:p>
@@ -6845,7 +6851,7 @@
           <a:p>
             <a:fld id="{D4F53BF9-51A7-479A-9F82-F12307D0B401}" type="datetimeFigureOut">
               <a:rPr lang="en-US" smtClean="0"/>
-              <a:t>10/27/2026</a:t>
+              <a:t>10/29/2026</a:t>
             </a:fld>
             <a:endParaRPr lang="en-US"/>
           </a:p>
@@ -7209,7 +7215,7 @@
           <a:p>
             <a:fld id="{D4F53BF9-51A7-479A-9F82-F12307D0B401}" type="datetimeFigureOut">
               <a:rPr lang="en-US" smtClean="0"/>
-              <a:t>10/27/2026</a:t>
+              <a:t>10/29/2026</a:t>
             </a:fld>
             <a:endParaRPr lang="en-US"/>
           </a:p>
@@ -7507,7 +7513,7 @@
           <a:p>
             <a:fld id="{D4F53BF9-51A7-479A-9F82-F12307D0B401}" type="datetimeFigureOut">
               <a:rPr lang="en-US" smtClean="0"/>
-              <a:t>10/27/2026</a:t>
+              <a:t>10/29/2026</a:t>
             </a:fld>
             <a:endParaRPr lang="en-US"/>
           </a:p>
@@ -7978,7 +7984,7 @@
           <a:p>
             <a:fld id="{D4F53BF9-51A7-479A-9F82-F12307D0B401}" type="datetimeFigureOut">
               <a:rPr lang="en-US" smtClean="0"/>
-              <a:t>10/27/2026</a:t>
+              <a:t>10/29/2026</a:t>
             </a:fld>
             <a:endParaRPr lang="en-US"/>
           </a:p>
@@ -8442,7 +8448,7 @@
           <a:p>
             <a:fld id="{D4F53BF9-51A7-479A-9F82-F12307D0B401}" type="datetimeFigureOut">
               <a:rPr lang="en-US" smtClean="0"/>
-              <a:t>10/27/2026</a:t>
+              <a:t>10/29/2026</a:t>
             </a:fld>
             <a:endParaRPr lang="en-US"/>
           </a:p>
@@ -8712,7 +8718,7 @@
           <a:p>
             <a:fld id="{D4F53BF9-51A7-479A-9F82-F12307D0B401}" type="datetimeFigureOut">
               <a:rPr lang="en-US" smtClean="0"/>
-              <a:t>10/27/2026</a:t>
+              <a:t>10/29/2026</a:t>
             </a:fld>
             <a:endParaRPr lang="en-US"/>
           </a:p>
@@ -8931,7 +8937,7 @@
           <a:p>
             <a:fld id="{D4F53BF9-51A7-479A-9F82-F12307D0B401}" type="datetimeFigureOut">
               <a:rPr lang="en-US" smtClean="0"/>
-              <a:t>10/27/2026</a:t>
+              <a:t>10/29/2026</a:t>
             </a:fld>
             <a:endParaRPr lang="en-US"/>
           </a:p>
@@ -9245,7 +9251,7 @@
           <a:p>
             <a:fld id="{D4F53BF9-51A7-479A-9F82-F12307D0B401}" type="datetimeFigureOut">
               <a:rPr lang="en-US" smtClean="0"/>
-              <a:t>10/27/2026</a:t>
+              <a:t>10/29/2026</a:t>
             </a:fld>
             <a:endParaRPr lang="en-US"/>
           </a:p>
@@ -10032,6 +10038,251 @@
           <p:cNvPr id="2" name="Title 1">
             <a:extLst>
               <a:ext uri="{FF2B5EF4-FFF2-40B4-BE49-F238E27FC236}">
+                <a16:creationId xmlns:a16="http://schemas.microsoft.com/office/drawing/2014/main" id="{8C7C6F8D-F38C-9801-5ADC-D11444ACB582}"/>
+              </a:ext>
+            </a:extLst>
+          </p:cNvPr>
+          <p:cNvSpPr>
+            <a:spLocks noGrp="1"/>
+          </p:cNvSpPr>
+          <p:nvPr>
+            <p:ph type="title"/>
+          </p:nvPr>
+        </p:nvSpPr>
+        <p:spPr>
+          <a:xfrm>
+            <a:off x="445477" y="282317"/>
+            <a:ext cx="6066927" cy="859491"/>
+          </a:xfrm>
+        </p:spPr>
+        <p:txBody>
+          <a:bodyPr>
+            <a:normAutofit/>
+          </a:bodyPr>
+          <a:lstStyle/>
+          <a:p>
+            <a:r>
+              <a:rPr lang="en-US" sz="4000">
+                <a:solidFill>
+                  <a:schemeClr val="tx1"/>
+                </a:solidFill>
+              </a:rPr>
+              <a:t>2d Intersection Builder</a:t>
+            </a:r>
+            <a:endParaRPr lang="en-US" sz="4000" dirty="0">
+              <a:solidFill>
+                <a:schemeClr val="tx1"/>
+              </a:solidFill>
+            </a:endParaRPr>
+          </a:p>
+        </p:txBody>
+      </p:sp>
+      <p:sp>
+        <p:nvSpPr>
+          <p:cNvPr id="3" name="Content Placeholder 2">
+            <a:extLst>
+              <a:ext uri="{FF2B5EF4-FFF2-40B4-BE49-F238E27FC236}">
+                <a16:creationId xmlns:a16="http://schemas.microsoft.com/office/drawing/2014/main" id="{82F72F78-AB0B-5033-5262-0A04BEC8EC30}"/>
+              </a:ext>
+            </a:extLst>
+          </p:cNvPr>
+          <p:cNvSpPr>
+            <a:spLocks noGrp="1"/>
+          </p:cNvSpPr>
+          <p:nvPr>
+            <p:ph idx="1"/>
+          </p:nvPr>
+        </p:nvSpPr>
+        <p:spPr>
+          <a:xfrm>
+            <a:off x="445478" y="1256704"/>
+            <a:ext cx="4314092" cy="4344592"/>
+          </a:xfrm>
+        </p:spPr>
+        <p:txBody>
+          <a:bodyPr>
+            <a:noAutofit/>
+          </a:bodyPr>
+          <a:lstStyle/>
+          <a:p>
+            <a:pPr marL="0" indent="0">
+              <a:buNone/>
+            </a:pPr>
+            <a:r>
+              <a:rPr lang="en-US" sz="2400" dirty="0">
+                <a:solidFill>
+                  <a:schemeClr val="tx1"/>
+                </a:solidFill>
+              </a:rPr>
+              <a:t>Users will be able to build an intersection by dragging and dropping components in the sandbox</a:t>
+            </a:r>
+          </a:p>
+          <a:p>
+            <a:pPr>
+              <a:lnSpc>
+                <a:spcPct val="200000"/>
+              </a:lnSpc>
+            </a:pPr>
+            <a:r>
+              <a:rPr lang="en-US" sz="2400" dirty="0">
+                <a:solidFill>
+                  <a:schemeClr val="tx1"/>
+                </a:solidFill>
+              </a:rPr>
+              <a:t>4-way, Roundabouts, T-intersection, etc.</a:t>
+            </a:r>
+          </a:p>
+          <a:p>
+            <a:pPr>
+              <a:lnSpc>
+                <a:spcPct val="200000"/>
+              </a:lnSpc>
+            </a:pPr>
+            <a:r>
+              <a:rPr lang="en-US" sz="2400" dirty="0">
+                <a:solidFill>
+                  <a:schemeClr val="tx1"/>
+                </a:solidFill>
+              </a:rPr>
+              <a:t>Signals, stop/yield signs</a:t>
+            </a:r>
+          </a:p>
+          <a:p>
+            <a:pPr>
+              <a:lnSpc>
+                <a:spcPct val="200000"/>
+              </a:lnSpc>
+            </a:pPr>
+            <a:r>
+              <a:rPr lang="en-US" sz="2400" dirty="0">
+                <a:solidFill>
+                  <a:schemeClr val="tx1"/>
+                </a:solidFill>
+              </a:rPr>
+              <a:t>Configure lanes and speed limits</a:t>
+            </a:r>
+          </a:p>
+        </p:txBody>
+      </p:sp>
+      <p:sp>
+        <p:nvSpPr>
+          <p:cNvPr id="9" name="Rectangle 8">
+            <a:extLst>
+              <a:ext uri="{FF2B5EF4-FFF2-40B4-BE49-F238E27FC236}">
+                <a16:creationId xmlns:a16="http://schemas.microsoft.com/office/drawing/2014/main" id="{7B76EB77-87C3-A564-4731-09D1E360D9BF}"/>
+              </a:ext>
+            </a:extLst>
+          </p:cNvPr>
+          <p:cNvSpPr/>
+          <p:nvPr/>
+        </p:nvSpPr>
+        <p:spPr>
+          <a:xfrm>
+            <a:off x="4759570" y="1540906"/>
+            <a:ext cx="6780198" cy="3776187"/>
+          </a:xfrm>
+          <a:prstGeom prst="rect">
+            <a:avLst/>
+          </a:prstGeom>
+          <a:solidFill>
+            <a:schemeClr val="tx1"/>
+          </a:solidFill>
+          <a:ln>
+            <a:solidFill>
+              <a:schemeClr val="tx1"/>
+            </a:solidFill>
+          </a:ln>
+        </p:spPr>
+        <p:style>
+          <a:lnRef idx="2">
+            <a:schemeClr val="accent1">
+              <a:shade val="15000"/>
+            </a:schemeClr>
+          </a:lnRef>
+          <a:fillRef idx="1">
+            <a:schemeClr val="accent1"/>
+          </a:fillRef>
+          <a:effectRef idx="0">
+            <a:schemeClr val="accent1"/>
+          </a:effectRef>
+          <a:fontRef idx="minor">
+            <a:schemeClr val="lt1"/>
+          </a:fontRef>
+        </p:style>
+        <p:txBody>
+          <a:bodyPr rtlCol="0" anchor="ctr"/>
+          <a:lstStyle/>
+          <a:p>
+            <a:pPr algn="ctr"/>
+            <a:endParaRPr lang="en-US" dirty="0"/>
+          </a:p>
+        </p:txBody>
+      </p:sp>
+      <p:pic>
+        <p:nvPicPr>
+          <p:cNvPr id="11" name="Picture 10">
+            <a:extLst>
+              <a:ext uri="{FF2B5EF4-FFF2-40B4-BE49-F238E27FC236}">
+                <a16:creationId xmlns:a16="http://schemas.microsoft.com/office/drawing/2014/main" id="{BF845DC4-61B5-2752-CA13-2A713088B8DE}"/>
+              </a:ext>
+            </a:extLst>
+          </p:cNvPr>
+          <p:cNvPicPr>
+            <a:picLocks noChangeAspect="1"/>
+          </p:cNvPicPr>
+          <p:nvPr/>
+        </p:nvPicPr>
+        <p:blipFill>
+          <a:blip r:embed="rId2"/>
+          <a:stretch>
+            <a:fillRect/>
+          </a:stretch>
+        </p:blipFill>
+        <p:spPr>
+          <a:xfrm>
+            <a:off x="4759570" y="1540905"/>
+            <a:ext cx="6780198" cy="3776187"/>
+          </a:xfrm>
+          <a:prstGeom prst="rect">
+            <a:avLst/>
+          </a:prstGeom>
+        </p:spPr>
+      </p:pic>
+    </p:spTree>
+    <p:extLst>
+      <p:ext uri="{BB962C8B-B14F-4D97-AF65-F5344CB8AC3E}">
+        <p14:creationId xmlns:p14="http://schemas.microsoft.com/office/powerpoint/2010/main" val="2256725576"/>
+      </p:ext>
+    </p:extLst>
+  </p:cSld>
+  <p:clrMapOvr>
+    <a:masterClrMapping/>
+  </p:clrMapOvr>
+</p:sld>
+</file>
+
+<file path=ppt/slides/slide3.xml><?xml version="1.0" encoding="utf-8"?>
+<p:sld xmlns:a="http://schemas.openxmlformats.org/drawingml/2006/main" xmlns:r="http://schemas.openxmlformats.org/officeDocument/2006/relationships" xmlns:p="http://schemas.openxmlformats.org/presentationml/2006/main">
+  <p:cSld>
+    <p:spTree>
+      <p:nvGrpSpPr>
+        <p:cNvPr id="1" name=""/>
+        <p:cNvGrpSpPr/>
+        <p:nvPr/>
+      </p:nvGrpSpPr>
+      <p:grpSpPr>
+        <a:xfrm>
+          <a:off x="0" y="0"/>
+          <a:ext cx="0" cy="0"/>
+          <a:chOff x="0" y="0"/>
+          <a:chExt cx="0" cy="0"/>
+        </a:xfrm>
+      </p:grpSpPr>
+      <p:sp>
+        <p:nvSpPr>
+          <p:cNvPr id="2" name="Title 1">
+            <a:extLst>
+              <a:ext uri="{FF2B5EF4-FFF2-40B4-BE49-F238E27FC236}">
                 <a16:creationId xmlns:a16="http://schemas.microsoft.com/office/drawing/2014/main" id="{017A6928-A1FD-AFE4-7BFB-C26DA00157E2}"/>
               </a:ext>
             </a:extLst>

</xml_diff>